<commit_message>
tweaked slides based on previous feedback
</commit_message>
<xml_diff>
--- a/Slides/Module 01.2 User Stories.pptx
+++ b/Slides/Module 01.2 User Stories.pptx
@@ -271,7 +271,7 @@
           <a:p>
             <a:fld id="{7C7E5181-6CF5-45F7-A87A-E0E0B1FD7549}" type="datetimeFigureOut">
               <a:rPr lang="en-US" smtClean="0"/>
-              <a:t>4/15/2026</a:t>
+              <a:t>5/1/2026</a:t>
             </a:fld>
             <a:endParaRPr lang="en-US"/>
           </a:p>
@@ -4625,7 +4625,7 @@
           <a:p>
             <a:fld id="{5D2A64DE-480B-420F-9649-4F8E696E08E0}" type="datetime1">
               <a:rPr lang="en-US" smtClean="0"/>
-              <a:t>4/15/2026</a:t>
+              <a:t>5/1/2026</a:t>
             </a:fld>
             <a:endParaRPr lang="en-US"/>
           </a:p>
@@ -4949,7 +4949,7 @@
           <a:p>
             <a:fld id="{EA476A42-A091-4468-A075-64A31BE59948}" type="datetime1">
               <a:rPr lang="en-US" smtClean="0"/>
-              <a:t>4/15/2026</a:t>
+              <a:t>5/1/2026</a:t>
             </a:fld>
             <a:endParaRPr lang="en-US"/>
           </a:p>
@@ -5147,7 +5147,7 @@
           <a:p>
             <a:fld id="{0D3616D0-8311-4107-9726-6B805E7D05BA}" type="datetime1">
               <a:rPr lang="en-US" smtClean="0"/>
-              <a:t>4/15/2026</a:t>
+              <a:t>5/1/2026</a:t>
             </a:fld>
             <a:endParaRPr lang="en-US"/>
           </a:p>
@@ -5355,7 +5355,7 @@
           <a:p>
             <a:fld id="{3BC2557A-5C88-417A-A763-5AC779462A5F}" type="datetime1">
               <a:rPr lang="en-US" smtClean="0"/>
-              <a:t>4/15/2026</a:t>
+              <a:t>5/1/2026</a:t>
             </a:fld>
             <a:endParaRPr lang="en-US"/>
           </a:p>
@@ -5879,7 +5879,7 @@
           <a:p>
             <a:fld id="{07C7BFD4-467E-4EDE-93EA-052F5B39A4E5}" type="datetime1">
               <a:rPr lang="en-US" smtClean="0"/>
-              <a:t>4/15/2026</a:t>
+              <a:t>5/1/2026</a:t>
             </a:fld>
             <a:endParaRPr lang="en-US"/>
           </a:p>
@@ -6129,7 +6129,7 @@
           <a:p>
             <a:fld id="{07C7BFD4-467E-4EDE-93EA-052F5B39A4E5}" type="datetime1">
               <a:rPr lang="en-US" smtClean="0"/>
-              <a:t>4/15/2026</a:t>
+              <a:t>5/1/2026</a:t>
             </a:fld>
             <a:endParaRPr lang="en-US"/>
           </a:p>
@@ -6311,7 +6311,7 @@
           <a:p>
             <a:fld id="{109E55A0-C911-4F03-82FC-7E5926047D46}" type="datetime1">
               <a:rPr lang="en-US" smtClean="0"/>
-              <a:t>4/15/2026</a:t>
+              <a:t>5/1/2026</a:t>
             </a:fld>
             <a:endParaRPr lang="en-US"/>
           </a:p>
@@ -6624,7 +6624,7 @@
           <a:p>
             <a:fld id="{A533CBE2-D5BE-47AC-ADC2-9CDFC1D0CF90}" type="datetime1">
               <a:rPr lang="en-US" smtClean="0"/>
-              <a:t>4/15/2026</a:t>
+              <a:t>5/1/2026</a:t>
             </a:fld>
             <a:endParaRPr lang="en-US"/>
           </a:p>
@@ -6925,7 +6925,7 @@
           <a:p>
             <a:fld id="{39B7EDB1-CE74-4951-85A2-0B01C2128E28}" type="datetime1">
               <a:rPr lang="en-US" smtClean="0"/>
-              <a:t>4/15/2026</a:t>
+              <a:t>5/1/2026</a:t>
             </a:fld>
             <a:endParaRPr lang="en-US"/>
           </a:p>
@@ -7373,7 +7373,7 @@
           <a:p>
             <a:fld id="{2BC7EB92-A5C2-4807-A9DC-9EDE6CBFB241}" type="datetime1">
               <a:rPr lang="en-US" smtClean="0"/>
-              <a:t>4/15/2026</a:t>
+              <a:t>5/1/2026</a:t>
             </a:fld>
             <a:endParaRPr lang="en-US"/>
           </a:p>
@@ -7486,7 +7486,7 @@
           <a:p>
             <a:fld id="{2B7B7EE0-7771-4CD5-9B2B-3550753A54A1}" type="datetime1">
               <a:rPr lang="en-US" smtClean="0"/>
-              <a:t>4/15/2026</a:t>
+              <a:t>5/1/2026</a:t>
             </a:fld>
             <a:endParaRPr lang="en-US"/>
           </a:p>
@@ -7797,7 +7797,7 @@
           <a:p>
             <a:fld id="{F8B318B3-0E87-4416-A9B8-D891968C2727}" type="datetime1">
               <a:rPr lang="en-US" smtClean="0"/>
-              <a:t>4/15/2026</a:t>
+              <a:t>5/1/2026</a:t>
             </a:fld>
             <a:endParaRPr lang="en-US"/>
           </a:p>
@@ -8038,7 +8038,7 @@
           <a:p>
             <a:fld id="{54D997E8-DDEE-43F1-8D9B-F8A1E11DE488}" type="datetime1">
               <a:rPr lang="en-US" smtClean="0"/>
-              <a:t>4/15/2026</a:t>
+              <a:t>5/1/2026</a:t>
             </a:fld>
             <a:endParaRPr lang="en-US"/>
           </a:p>
@@ -8710,7 +8710,7 @@
           <a:lstStyle/>
           <a:p>
             <a:r>
-              <a:rPr lang="en-US"/>
+              <a:rPr lang="en-US" dirty="0"/>
               <a:t>Capabilities: “what”</a:t>
             </a:r>
           </a:p>
@@ -8923,6 +8923,208 @@
                 <a:latin typeface="Ink Free" panose="03080402000500000000" pitchFamily="66" charset="0"/>
               </a:rPr>
               <a:t>so that I can &lt;get some benefit&gt;</a:t>
+            </a:r>
+          </a:p>
+        </p:txBody>
+      </p:sp>
+      <p:sp>
+        <p:nvSpPr>
+          <p:cNvPr id="4" name="Content Placeholder 2">
+            <a:extLst>
+              <a:ext uri="{FF2B5EF4-FFF2-40B4-BE49-F238E27FC236}">
+                <a16:creationId xmlns:a16="http://schemas.microsoft.com/office/drawing/2014/main" id="{BC753727-7328-11BB-21E7-911889024DC6}"/>
+              </a:ext>
+            </a:extLst>
+          </p:cNvPr>
+          <p:cNvSpPr txBox="1">
+            <a:spLocks/>
+          </p:cNvSpPr>
+          <p:nvPr/>
+        </p:nvSpPr>
+        <p:spPr>
+          <a:xfrm>
+            <a:off x="8100170" y="700604"/>
+            <a:ext cx="3253630" cy="721385"/>
+          </a:xfrm>
+          <a:prstGeom prst="rect">
+            <a:avLst/>
+          </a:prstGeom>
+        </p:spPr>
+        <p:txBody>
+          <a:bodyPr vert="horz" lIns="91440" tIns="45720" rIns="91440" bIns="45720" rtlCol="0">
+            <a:normAutofit/>
+          </a:bodyPr>
+          <a:lstStyle>
+            <a:lvl1pPr marL="228600" indent="-228600" algn="l" defTabSz="914400" rtl="0" eaLnBrk="1" latinLnBrk="0" hangingPunct="1">
+              <a:lnSpc>
+                <a:spcPct val="100000"/>
+              </a:lnSpc>
+              <a:spcBef>
+                <a:spcPts val="1000"/>
+              </a:spcBef>
+              <a:buFont typeface="Arial" panose="020B0604020202020204" pitchFamily="34" charset="0"/>
+              <a:buChar char="•"/>
+              <a:defRPr sz="2800" kern="1200">
+                <a:solidFill>
+                  <a:schemeClr val="tx1"/>
+                </a:solidFill>
+                <a:latin typeface="+mn-lt"/>
+                <a:ea typeface="+mn-ea"/>
+                <a:cs typeface="+mn-cs"/>
+              </a:defRPr>
+            </a:lvl1pPr>
+            <a:lvl2pPr marL="685800" indent="-228600" algn="l" defTabSz="914400" rtl="0" eaLnBrk="1" latinLnBrk="0" hangingPunct="1">
+              <a:lnSpc>
+                <a:spcPct val="100000"/>
+              </a:lnSpc>
+              <a:spcBef>
+                <a:spcPts val="500"/>
+              </a:spcBef>
+              <a:buFont typeface="Arial" panose="020B0604020202020204" pitchFamily="34" charset="0"/>
+              <a:buChar char="•"/>
+              <a:defRPr sz="2400" kern="1200">
+                <a:solidFill>
+                  <a:schemeClr val="tx1"/>
+                </a:solidFill>
+                <a:latin typeface="+mn-lt"/>
+                <a:ea typeface="+mn-ea"/>
+                <a:cs typeface="+mn-cs"/>
+              </a:defRPr>
+            </a:lvl2pPr>
+            <a:lvl3pPr marL="1143000" indent="-228600" algn="l" defTabSz="914400" rtl="0" eaLnBrk="1" latinLnBrk="0" hangingPunct="1">
+              <a:lnSpc>
+                <a:spcPct val="100000"/>
+              </a:lnSpc>
+              <a:spcBef>
+                <a:spcPts val="500"/>
+              </a:spcBef>
+              <a:buFont typeface="Arial" panose="020B0604020202020204" pitchFamily="34" charset="0"/>
+              <a:buChar char="•"/>
+              <a:defRPr sz="2000" kern="1200">
+                <a:solidFill>
+                  <a:schemeClr val="tx1"/>
+                </a:solidFill>
+                <a:latin typeface="+mn-lt"/>
+                <a:ea typeface="+mn-ea"/>
+                <a:cs typeface="+mn-cs"/>
+              </a:defRPr>
+            </a:lvl3pPr>
+            <a:lvl4pPr marL="1600200" indent="-228600" algn="l" defTabSz="914400" rtl="0" eaLnBrk="1" latinLnBrk="0" hangingPunct="1">
+              <a:lnSpc>
+                <a:spcPct val="100000"/>
+              </a:lnSpc>
+              <a:spcBef>
+                <a:spcPts val="500"/>
+              </a:spcBef>
+              <a:buFont typeface="Arial" panose="020B0604020202020204" pitchFamily="34" charset="0"/>
+              <a:buChar char="•"/>
+              <a:defRPr sz="1800" kern="1200">
+                <a:solidFill>
+                  <a:schemeClr val="tx1"/>
+                </a:solidFill>
+                <a:latin typeface="+mn-lt"/>
+                <a:ea typeface="+mn-ea"/>
+                <a:cs typeface="+mn-cs"/>
+              </a:defRPr>
+            </a:lvl4pPr>
+            <a:lvl5pPr marL="2057400" indent="-228600" algn="l" defTabSz="914400" rtl="0" eaLnBrk="1" latinLnBrk="0" hangingPunct="1">
+              <a:lnSpc>
+                <a:spcPct val="100000"/>
+              </a:lnSpc>
+              <a:spcBef>
+                <a:spcPts val="500"/>
+              </a:spcBef>
+              <a:buFont typeface="Arial" panose="020B0604020202020204" pitchFamily="34" charset="0"/>
+              <a:buChar char="•"/>
+              <a:defRPr sz="1800" kern="1200">
+                <a:solidFill>
+                  <a:schemeClr val="tx1"/>
+                </a:solidFill>
+                <a:latin typeface="+mn-lt"/>
+                <a:ea typeface="+mn-ea"/>
+                <a:cs typeface="+mn-cs"/>
+              </a:defRPr>
+            </a:lvl5pPr>
+            <a:lvl6pPr marL="2514600" indent="-228600" algn="l" defTabSz="914400" rtl="0" eaLnBrk="1" latinLnBrk="0" hangingPunct="1">
+              <a:lnSpc>
+                <a:spcPct val="90000"/>
+              </a:lnSpc>
+              <a:spcBef>
+                <a:spcPts val="500"/>
+              </a:spcBef>
+              <a:buFont typeface="Arial" panose="020B0604020202020204" pitchFamily="34" charset="0"/>
+              <a:buChar char="•"/>
+              <a:defRPr sz="1800" kern="1200">
+                <a:solidFill>
+                  <a:schemeClr val="tx1"/>
+                </a:solidFill>
+                <a:latin typeface="+mn-lt"/>
+                <a:ea typeface="+mn-ea"/>
+                <a:cs typeface="+mn-cs"/>
+              </a:defRPr>
+            </a:lvl6pPr>
+            <a:lvl7pPr marL="2971800" indent="-228600" algn="l" defTabSz="914400" rtl="0" eaLnBrk="1" latinLnBrk="0" hangingPunct="1">
+              <a:lnSpc>
+                <a:spcPct val="90000"/>
+              </a:lnSpc>
+              <a:spcBef>
+                <a:spcPts val="500"/>
+              </a:spcBef>
+              <a:buFont typeface="Arial" panose="020B0604020202020204" pitchFamily="34" charset="0"/>
+              <a:buChar char="•"/>
+              <a:defRPr sz="1800" kern="1200">
+                <a:solidFill>
+                  <a:schemeClr val="tx1"/>
+                </a:solidFill>
+                <a:latin typeface="+mn-lt"/>
+                <a:ea typeface="+mn-ea"/>
+                <a:cs typeface="+mn-cs"/>
+              </a:defRPr>
+            </a:lvl7pPr>
+            <a:lvl8pPr marL="3429000" indent="-228600" algn="l" defTabSz="914400" rtl="0" eaLnBrk="1" latinLnBrk="0" hangingPunct="1">
+              <a:lnSpc>
+                <a:spcPct val="90000"/>
+              </a:lnSpc>
+              <a:spcBef>
+                <a:spcPts val="500"/>
+              </a:spcBef>
+              <a:buFont typeface="Arial" panose="020B0604020202020204" pitchFamily="34" charset="0"/>
+              <a:buChar char="•"/>
+              <a:defRPr sz="1800" kern="1200">
+                <a:solidFill>
+                  <a:schemeClr val="tx1"/>
+                </a:solidFill>
+                <a:latin typeface="+mn-lt"/>
+                <a:ea typeface="+mn-ea"/>
+                <a:cs typeface="+mn-cs"/>
+              </a:defRPr>
+            </a:lvl8pPr>
+            <a:lvl9pPr marL="3886200" indent="-228600" algn="l" defTabSz="914400" rtl="0" eaLnBrk="1" latinLnBrk="0" hangingPunct="1">
+              <a:lnSpc>
+                <a:spcPct val="90000"/>
+              </a:lnSpc>
+              <a:spcBef>
+                <a:spcPts val="500"/>
+              </a:spcBef>
+              <a:buFont typeface="Arial" panose="020B0604020202020204" pitchFamily="34" charset="0"/>
+              <a:buChar char="•"/>
+              <a:defRPr sz="1800" kern="1200">
+                <a:solidFill>
+                  <a:schemeClr val="tx1"/>
+                </a:solidFill>
+                <a:latin typeface="+mn-lt"/>
+                <a:ea typeface="+mn-ea"/>
+                <a:cs typeface="+mn-cs"/>
+              </a:defRPr>
+            </a:lvl9pPr>
+          </a:lstStyle>
+          <a:p>
+            <a:pPr marL="0" indent="0">
+              <a:buNone/>
+            </a:pPr>
+            <a:r>
+              <a:rPr lang="en-US" i="1" dirty="0"/>
+              <a:t>Think verb, not noun</a:t>
             </a:r>
           </a:p>
         </p:txBody>
@@ -10199,8 +10401,43 @@
         </p:nvSpPr>
         <p:spPr>
           <a:xfrm>
-            <a:off x="682752" y="365125"/>
-            <a:ext cx="3822700" cy="1900238"/>
+            <a:off x="682751" y="365125"/>
+            <a:ext cx="4364261" cy="1855562"/>
+          </a:xfrm>
+        </p:spPr>
+        <p:txBody>
+          <a:bodyPr>
+            <a:noAutofit/>
+          </a:bodyPr>
+          <a:lstStyle/>
+          <a:p>
+            <a:r>
+              <a:rPr lang="en-US" sz="3600" dirty="0"/>
+              <a:t>Worked Example: Pothole reporting system</a:t>
+            </a:r>
+          </a:p>
+        </p:txBody>
+      </p:sp>
+      <p:sp>
+        <p:nvSpPr>
+          <p:cNvPr id="3" name="Content Placeholder 2">
+            <a:extLst>
+              <a:ext uri="{FF2B5EF4-FFF2-40B4-BE49-F238E27FC236}">
+                <a16:creationId xmlns:a16="http://schemas.microsoft.com/office/drawing/2014/main" id="{FEA918B7-4C5F-8518-63E1-5C4C6B7BC359}"/>
+              </a:ext>
+            </a:extLst>
+          </p:cNvPr>
+          <p:cNvSpPr>
+            <a:spLocks noGrp="1"/>
+          </p:cNvSpPr>
+          <p:nvPr>
+            <p:ph idx="4294967295"/>
+          </p:nvPr>
+        </p:nvSpPr>
+        <p:spPr>
+          <a:xfrm>
+            <a:off x="682750" y="2529444"/>
+            <a:ext cx="4103005" cy="3089379"/>
           </a:xfrm>
         </p:spPr>
         <p:txBody>
@@ -10209,46 +10446,11 @@
           </a:bodyPr>
           <a:lstStyle/>
           <a:p>
-            <a:r>
-              <a:rPr lang="en-US" sz="3100"/>
-              <a:t>Worked Example: Pothole reporting system</a:t>
-            </a:r>
-          </a:p>
-        </p:txBody>
-      </p:sp>
-      <p:sp>
-        <p:nvSpPr>
-          <p:cNvPr id="3" name="Content Placeholder 2">
-            <a:extLst>
-              <a:ext uri="{FF2B5EF4-FFF2-40B4-BE49-F238E27FC236}">
-                <a16:creationId xmlns:a16="http://schemas.microsoft.com/office/drawing/2014/main" id="{FEA918B7-4C5F-8518-63E1-5C4C6B7BC359}"/>
-              </a:ext>
-            </a:extLst>
-          </p:cNvPr>
-          <p:cNvSpPr>
-            <a:spLocks noGrp="1"/>
-          </p:cNvSpPr>
-          <p:nvPr>
-            <p:ph idx="4294967295"/>
-          </p:nvPr>
-        </p:nvSpPr>
-        <p:spPr>
-          <a:xfrm>
-            <a:off x="682752" y="2433638"/>
-            <a:ext cx="3822700" cy="3743325"/>
-          </a:xfrm>
-        </p:spPr>
-        <p:txBody>
-          <a:bodyPr>
-            <a:normAutofit/>
-          </a:bodyPr>
-          <a:lstStyle/>
-          <a:p>
             <a:pPr marL="0" indent="0">
               <a:buNone/>
             </a:pPr>
             <a:r>
-              <a:rPr lang="en-US" sz="2000"/>
+              <a:rPr lang="en-US" dirty="0"/>
               <a:t>A town is designing a system where citizens can a report potholes and the town can monitor progress on repairing them.</a:t>
             </a:r>
           </a:p>
@@ -10766,7 +10968,7 @@
           <a:p>
             <a:r>
               <a:rPr lang="en-US" dirty="0"/>
-              <a:t>As a pothole-repair-truck driver, I want the system to display the potholes I should be working on today.</a:t>
+              <a:t>As a pothole-repair-truck driver, I want the system to display the potholes I should be working on today, so that … (?)</a:t>
             </a:r>
           </a:p>
         </p:txBody>
@@ -11118,7 +11320,7 @@
           <a:p>
             <a:r>
               <a:rPr lang="en-US" dirty="0"/>
-              <a:t>As a pothole-repair-truck driver, I want the system to display the potholes I should be working on today.</a:t>
+              <a:t>As a pothole-repair-truck driver, I want the system to display the potholes I should be working on today, so that I can view and report my progress for the day.</a:t>
             </a:r>
           </a:p>
           <a:p>
@@ -11343,8 +11545,11 @@
           <a:p>
             <a:r>
               <a:rPr lang="en-US" dirty="0"/>
-              <a:t>As a maintenance supervisor, I want to be able to control the order in which potholes are repaired</a:t>
-            </a:r>
+              <a:t>As a maintenance supervisor, I want to be able to control the order in which potholes are repaired, so that… (?)</a:t>
+            </a:r>
+          </a:p>
+          <a:p>
+            <a:endParaRPr lang="en-US" dirty="0"/>
           </a:p>
           <a:p>
             <a:endParaRPr lang="en-US" dirty="0"/>
@@ -11539,13 +11744,13 @@
         </p:spPr>
         <p:txBody>
           <a:bodyPr>
-            <a:normAutofit/>
+            <a:normAutofit lnSpcReduction="10000"/>
           </a:bodyPr>
           <a:lstStyle/>
           <a:p>
             <a:r>
               <a:rPr lang="en-US" dirty="0"/>
-              <a:t>As a maintenance supervisor, I want to be able to control the order in which potholes are repaired</a:t>
+              <a:t>As a maintenance supervisor, I want to be able to control the order in which potholes are repaired, so that complaints to city hall are minimized.</a:t>
             </a:r>
           </a:p>
           <a:p>
@@ -17636,7 +17841,7 @@
           <a:lstStyle/>
           <a:p>
             <a:r>
-              <a:rPr lang="en-US"/>
+              <a:rPr lang="en-US" dirty="0"/>
               <a:t>Roles: “who”</a:t>
             </a:r>
           </a:p>
@@ -17661,7 +17866,7 @@
         <p:spPr>
           <a:xfrm>
             <a:off x="838199" y="1500160"/>
-            <a:ext cx="9895450" cy="4351338"/>
+            <a:ext cx="10193978" cy="4351338"/>
           </a:xfrm>
         </p:spPr>
         <p:txBody>
@@ -17672,13 +17877,26 @@
           <a:p>
             <a:r>
               <a:rPr lang="en-US" dirty="0"/>
-              <a:t>Roles are positions or functions that people inhabit!</a:t>
+              <a:t>Roles are positions or functions that people inhabit! The person is not you! It is the user, not customer </a:t>
             </a:r>
           </a:p>
           <a:p>
             <a:pPr lvl="1"/>
             <a:r>
               <a:rPr lang="en-US" dirty="0"/>
+              <a:t>You may want to build software to develop skills, or to make a codebase more maintainable. That’s good, but it doesn’t fit as a user story.</a:t>
+            </a:r>
+          </a:p>
+          <a:p>
+            <a:r>
+              <a:rPr lang="en-US" dirty="0"/>
+              <a:t>User stories are for users in a specific role:</a:t>
+            </a:r>
+          </a:p>
+          <a:p>
+            <a:pPr lvl="1"/>
+            <a:r>
+              <a:rPr lang="en-US" dirty="0"/>
               <a:t>“As a web server…” is not a user story!</a:t>
             </a:r>
           </a:p>
@@ -17697,21 +17915,10 @@
             </a:r>
           </a:p>
           <a:p>
-            <a:pPr lvl="1"/>
+            <a:pPr marL="0" indent="0">
+              <a:buNone/>
+            </a:pPr>
             <a:endParaRPr lang="en-US" dirty="0"/>
-          </a:p>
-          <a:p>
-            <a:r>
-              <a:rPr lang="en-US" dirty="0"/>
-              <a:t>The person is not you!</a:t>
-            </a:r>
-          </a:p>
-          <a:p>
-            <a:pPr lvl="1"/>
-            <a:r>
-              <a:rPr lang="en-US" dirty="0"/>
-              <a:t>You may want to build software to develop skills, or to make a codebase more maintainable. That’s good, but it doesn’t fit as a user story.</a:t>
-            </a:r>
           </a:p>
         </p:txBody>
       </p:sp>
@@ -17966,6 +18173,208 @@
           </a:p>
         </p:txBody>
       </p:sp>
+      <p:sp>
+        <p:nvSpPr>
+          <p:cNvPr id="4" name="Content Placeholder 2">
+            <a:extLst>
+              <a:ext uri="{FF2B5EF4-FFF2-40B4-BE49-F238E27FC236}">
+                <a16:creationId xmlns:a16="http://schemas.microsoft.com/office/drawing/2014/main" id="{EF0DB432-7C4E-48EF-E6F2-8B128C86E4E5}"/>
+              </a:ext>
+            </a:extLst>
+          </p:cNvPr>
+          <p:cNvSpPr txBox="1">
+            <a:spLocks/>
+          </p:cNvSpPr>
+          <p:nvPr/>
+        </p:nvSpPr>
+        <p:spPr>
+          <a:xfrm>
+            <a:off x="8100170" y="700604"/>
+            <a:ext cx="3253630" cy="721385"/>
+          </a:xfrm>
+          <a:prstGeom prst="rect">
+            <a:avLst/>
+          </a:prstGeom>
+        </p:spPr>
+        <p:txBody>
+          <a:bodyPr vert="horz" lIns="91440" tIns="45720" rIns="91440" bIns="45720" rtlCol="0">
+            <a:normAutofit/>
+          </a:bodyPr>
+          <a:lstStyle>
+            <a:lvl1pPr marL="228600" indent="-228600" algn="l" defTabSz="914400" rtl="0" eaLnBrk="1" latinLnBrk="0" hangingPunct="1">
+              <a:lnSpc>
+                <a:spcPct val="100000"/>
+              </a:lnSpc>
+              <a:spcBef>
+                <a:spcPts val="1000"/>
+              </a:spcBef>
+              <a:buFont typeface="Arial" panose="020B0604020202020204" pitchFamily="34" charset="0"/>
+              <a:buChar char="•"/>
+              <a:defRPr sz="2800" kern="1200">
+                <a:solidFill>
+                  <a:schemeClr val="tx1"/>
+                </a:solidFill>
+                <a:latin typeface="+mn-lt"/>
+                <a:ea typeface="+mn-ea"/>
+                <a:cs typeface="+mn-cs"/>
+              </a:defRPr>
+            </a:lvl1pPr>
+            <a:lvl2pPr marL="685800" indent="-228600" algn="l" defTabSz="914400" rtl="0" eaLnBrk="1" latinLnBrk="0" hangingPunct="1">
+              <a:lnSpc>
+                <a:spcPct val="100000"/>
+              </a:lnSpc>
+              <a:spcBef>
+                <a:spcPts val="500"/>
+              </a:spcBef>
+              <a:buFont typeface="Arial" panose="020B0604020202020204" pitchFamily="34" charset="0"/>
+              <a:buChar char="•"/>
+              <a:defRPr sz="2400" kern="1200">
+                <a:solidFill>
+                  <a:schemeClr val="tx1"/>
+                </a:solidFill>
+                <a:latin typeface="+mn-lt"/>
+                <a:ea typeface="+mn-ea"/>
+                <a:cs typeface="+mn-cs"/>
+              </a:defRPr>
+            </a:lvl2pPr>
+            <a:lvl3pPr marL="1143000" indent="-228600" algn="l" defTabSz="914400" rtl="0" eaLnBrk="1" latinLnBrk="0" hangingPunct="1">
+              <a:lnSpc>
+                <a:spcPct val="100000"/>
+              </a:lnSpc>
+              <a:spcBef>
+                <a:spcPts val="500"/>
+              </a:spcBef>
+              <a:buFont typeface="Arial" panose="020B0604020202020204" pitchFamily="34" charset="0"/>
+              <a:buChar char="•"/>
+              <a:defRPr sz="2000" kern="1200">
+                <a:solidFill>
+                  <a:schemeClr val="tx1"/>
+                </a:solidFill>
+                <a:latin typeface="+mn-lt"/>
+                <a:ea typeface="+mn-ea"/>
+                <a:cs typeface="+mn-cs"/>
+              </a:defRPr>
+            </a:lvl3pPr>
+            <a:lvl4pPr marL="1600200" indent="-228600" algn="l" defTabSz="914400" rtl="0" eaLnBrk="1" latinLnBrk="0" hangingPunct="1">
+              <a:lnSpc>
+                <a:spcPct val="100000"/>
+              </a:lnSpc>
+              <a:spcBef>
+                <a:spcPts val="500"/>
+              </a:spcBef>
+              <a:buFont typeface="Arial" panose="020B0604020202020204" pitchFamily="34" charset="0"/>
+              <a:buChar char="•"/>
+              <a:defRPr sz="1800" kern="1200">
+                <a:solidFill>
+                  <a:schemeClr val="tx1"/>
+                </a:solidFill>
+                <a:latin typeface="+mn-lt"/>
+                <a:ea typeface="+mn-ea"/>
+                <a:cs typeface="+mn-cs"/>
+              </a:defRPr>
+            </a:lvl4pPr>
+            <a:lvl5pPr marL="2057400" indent="-228600" algn="l" defTabSz="914400" rtl="0" eaLnBrk="1" latinLnBrk="0" hangingPunct="1">
+              <a:lnSpc>
+                <a:spcPct val="100000"/>
+              </a:lnSpc>
+              <a:spcBef>
+                <a:spcPts val="500"/>
+              </a:spcBef>
+              <a:buFont typeface="Arial" panose="020B0604020202020204" pitchFamily="34" charset="0"/>
+              <a:buChar char="•"/>
+              <a:defRPr sz="1800" kern="1200">
+                <a:solidFill>
+                  <a:schemeClr val="tx1"/>
+                </a:solidFill>
+                <a:latin typeface="+mn-lt"/>
+                <a:ea typeface="+mn-ea"/>
+                <a:cs typeface="+mn-cs"/>
+              </a:defRPr>
+            </a:lvl5pPr>
+            <a:lvl6pPr marL="2514600" indent="-228600" algn="l" defTabSz="914400" rtl="0" eaLnBrk="1" latinLnBrk="0" hangingPunct="1">
+              <a:lnSpc>
+                <a:spcPct val="90000"/>
+              </a:lnSpc>
+              <a:spcBef>
+                <a:spcPts val="500"/>
+              </a:spcBef>
+              <a:buFont typeface="Arial" panose="020B0604020202020204" pitchFamily="34" charset="0"/>
+              <a:buChar char="•"/>
+              <a:defRPr sz="1800" kern="1200">
+                <a:solidFill>
+                  <a:schemeClr val="tx1"/>
+                </a:solidFill>
+                <a:latin typeface="+mn-lt"/>
+                <a:ea typeface="+mn-ea"/>
+                <a:cs typeface="+mn-cs"/>
+              </a:defRPr>
+            </a:lvl6pPr>
+            <a:lvl7pPr marL="2971800" indent="-228600" algn="l" defTabSz="914400" rtl="0" eaLnBrk="1" latinLnBrk="0" hangingPunct="1">
+              <a:lnSpc>
+                <a:spcPct val="90000"/>
+              </a:lnSpc>
+              <a:spcBef>
+                <a:spcPts val="500"/>
+              </a:spcBef>
+              <a:buFont typeface="Arial" panose="020B0604020202020204" pitchFamily="34" charset="0"/>
+              <a:buChar char="•"/>
+              <a:defRPr sz="1800" kern="1200">
+                <a:solidFill>
+                  <a:schemeClr val="tx1"/>
+                </a:solidFill>
+                <a:latin typeface="+mn-lt"/>
+                <a:ea typeface="+mn-ea"/>
+                <a:cs typeface="+mn-cs"/>
+              </a:defRPr>
+            </a:lvl7pPr>
+            <a:lvl8pPr marL="3429000" indent="-228600" algn="l" defTabSz="914400" rtl="0" eaLnBrk="1" latinLnBrk="0" hangingPunct="1">
+              <a:lnSpc>
+                <a:spcPct val="90000"/>
+              </a:lnSpc>
+              <a:spcBef>
+                <a:spcPts val="500"/>
+              </a:spcBef>
+              <a:buFont typeface="Arial" panose="020B0604020202020204" pitchFamily="34" charset="0"/>
+              <a:buChar char="•"/>
+              <a:defRPr sz="1800" kern="1200">
+                <a:solidFill>
+                  <a:schemeClr val="tx1"/>
+                </a:solidFill>
+                <a:latin typeface="+mn-lt"/>
+                <a:ea typeface="+mn-ea"/>
+                <a:cs typeface="+mn-cs"/>
+              </a:defRPr>
+            </a:lvl8pPr>
+            <a:lvl9pPr marL="3886200" indent="-228600" algn="l" defTabSz="914400" rtl="0" eaLnBrk="1" latinLnBrk="0" hangingPunct="1">
+              <a:lnSpc>
+                <a:spcPct val="90000"/>
+              </a:lnSpc>
+              <a:spcBef>
+                <a:spcPts val="500"/>
+              </a:spcBef>
+              <a:buFont typeface="Arial" panose="020B0604020202020204" pitchFamily="34" charset="0"/>
+              <a:buChar char="•"/>
+              <a:defRPr sz="1800" kern="1200">
+                <a:solidFill>
+                  <a:schemeClr val="tx1"/>
+                </a:solidFill>
+                <a:latin typeface="+mn-lt"/>
+                <a:ea typeface="+mn-ea"/>
+                <a:cs typeface="+mn-cs"/>
+              </a:defRPr>
+            </a:lvl9pPr>
+          </a:lstStyle>
+          <a:p>
+            <a:pPr marL="0" indent="0">
+              <a:buNone/>
+            </a:pPr>
+            <a:r>
+              <a:rPr lang="en-US" i="1" dirty="0"/>
+              <a:t>Think “Canvas roles”</a:t>
+            </a:r>
+          </a:p>
+        </p:txBody>
+      </p:sp>
     </p:spTree>
     <p:extLst>
       <p:ext uri="{BB962C8B-B14F-4D97-AF65-F5344CB8AC3E}">
@@ -18054,7 +18463,7 @@
         <p:spPr>
           <a:xfrm>
             <a:off x="838199" y="1500160"/>
-            <a:ext cx="8066649" cy="4351338"/>
+            <a:ext cx="8595958" cy="4351338"/>
           </a:xfrm>
         </p:spPr>
         <p:txBody>
@@ -18089,7 +18498,15 @@
             <a:pPr lvl="1"/>
             <a:r>
               <a:rPr lang="en-US" dirty="0"/>
-              <a:t>“As a teacher at Northeastern, I want to be able to access a laser cutter so I can finish an art project” is not a good user story.</a:t>
+              <a:t>“As a teacher at Northeastern, I want to be able to access a laser cutter so I can finish an art project” is not a good user story. (</a:t>
+            </a:r>
+            <a:r>
+              <a:rPr lang="en-US" i="1" dirty="0"/>
+              <a:t>It is too general</a:t>
+            </a:r>
+            <a:r>
+              <a:rPr lang="en-US" dirty="0"/>
+              <a:t>)</a:t>
             </a:r>
           </a:p>
         </p:txBody>

</xml_diff>